<commit_message>
modificaciones a la presentación
</commit_message>
<xml_diff>
--- a/github_clase_CCGUC.pptx
+++ b/github_clase_CCGUC.pptx
@@ -3738,7 +3738,7 @@
         </p:nvSpPr>
         <p:spPr>
           <a:xfrm>
-            <a:off x="5422392" y="4215384"/>
+            <a:off x="5422392" y="3995110"/>
             <a:ext cx="3355848" cy="274320"/>
           </a:xfrm>
           <a:prstGeom prst="rect">
@@ -3788,7 +3788,7 @@
         </p:nvSpPr>
         <p:spPr>
           <a:xfrm>
-            <a:off x="5422392" y="4526280"/>
+            <a:off x="5416791" y="4349092"/>
             <a:ext cx="3355848" cy="274320"/>
           </a:xfrm>
           <a:prstGeom prst="rect">
@@ -3827,7 +3827,7 @@
         </p:nvSpPr>
         <p:spPr>
           <a:xfrm>
-            <a:off x="5422392" y="4837176"/>
+            <a:off x="5422392" y="4637825"/>
             <a:ext cx="3355848" cy="274320"/>
           </a:xfrm>
           <a:prstGeom prst="rect">
@@ -8229,7 +8229,39 @@
                   <a:srgbClr val="FFFFFF"/>
                 </a:solidFill>
               </a:rPr>
-              <a:t>Prepara y commitea los cambios</a:t>
+              <a:t>Prepara y commitea </a:t>
+            </a:r>
+            <a:r>
+              <a:rPr lang="en-US" sz="1200" b="1" dirty="0" err="1">
+                <a:solidFill>
+                  <a:srgbClr val="FFFFFF"/>
+                </a:solidFill>
+              </a:rPr>
+              <a:t>los</a:t>
+            </a:r>
+            <a:r>
+              <a:rPr lang="en-US" sz="1200" b="1" dirty="0">
+                <a:solidFill>
+                  <a:srgbClr val="FFFFFF"/>
+                </a:solidFill>
+              </a:rPr>
+              <a:t> </a:t>
+            </a:r>
+            <a:r>
+              <a:rPr lang="en-US" sz="1200" b="1" dirty="0" err="1">
+                <a:solidFill>
+                  <a:srgbClr val="FFFFFF"/>
+                </a:solidFill>
+              </a:rPr>
+              <a:t>cambios</a:t>
+            </a:r>
+            <a:r>
+              <a:rPr lang="en-US" sz="1200" b="1" dirty="0">
+                <a:solidFill>
+                  <a:srgbClr val="FFFFFF"/>
+                </a:solidFill>
+              </a:rPr>
+              <a:t>&gt; “git add.”</a:t>
             </a:r>
             <a:endParaRPr lang="en-US" sz="1200" dirty="0"/>
           </a:p>
@@ -8265,7 +8297,36 @@
                   <a:srgbClr val="8A9BB0"/>
                 </a:solidFill>
               </a:rPr>
-              <a:t>git add . agrega todo lo modificado. git commit -m guarda el punto con un mensaje descriptivo.</a:t>
+              <a:t>git add . </a:t>
+            </a:r>
+            <a:r>
+              <a:rPr lang="en-US" sz="1100" dirty="0" err="1">
+                <a:solidFill>
+                  <a:srgbClr val="8A9BB0"/>
+                </a:solidFill>
+              </a:rPr>
+              <a:t>agrega</a:t>
+            </a:r>
+            <a:r>
+              <a:rPr lang="en-US" sz="1100" dirty="0">
+                <a:solidFill>
+                  <a:srgbClr val="8A9BB0"/>
+                </a:solidFill>
+              </a:rPr>
+              <a:t> todo lo modificado. </a:t>
+            </a:r>
+          </a:p>
+          <a:p>
+            <a:pPr marL="0" indent="0">
+              <a:buNone/>
+            </a:pPr>
+            <a:r>
+              <a:rPr lang="en-US" sz="1100" dirty="0">
+                <a:solidFill>
+                  <a:srgbClr val="8A9BB0"/>
+                </a:solidFill>
+              </a:rPr>
+              <a:t>git commit -m guarda el punto con un mensaje descriptivo.</a:t>
             </a:r>
             <a:endParaRPr lang="en-US" sz="1100" dirty="0"/>
           </a:p>
@@ -8767,7 +8828,39 @@
                   <a:srgbClr val="FFFFFF"/>
                 </a:solidFill>
               </a:rPr>
-              <a:t> a GitHub (push origin branch)</a:t>
+              <a:t> al </a:t>
+            </a:r>
+            <a:r>
+              <a:rPr lang="en-US" sz="1200" b="1" dirty="0" err="1">
+                <a:solidFill>
+                  <a:srgbClr val="FFFFFF"/>
+                </a:solidFill>
+              </a:rPr>
+              <a:t>servidor</a:t>
+            </a:r>
+            <a:r>
+              <a:rPr lang="en-US" sz="1200" b="1" dirty="0">
+                <a:solidFill>
+                  <a:srgbClr val="FFFFFF"/>
+                </a:solidFill>
+              </a:rPr>
+              <a:t> “git push </a:t>
+            </a:r>
+            <a:r>
+              <a:rPr lang="en-US" sz="1200" b="1" dirty="0" err="1">
+                <a:solidFill>
+                  <a:srgbClr val="FFFFFF"/>
+                </a:solidFill>
+              </a:rPr>
+              <a:t>oirigin</a:t>
+            </a:r>
+            <a:r>
+              <a:rPr lang="en-US" sz="1200" b="1" dirty="0">
+                <a:solidFill>
+                  <a:srgbClr val="FFFFFF"/>
+                </a:solidFill>
+              </a:rPr>
+              <a:t> branch”</a:t>
             </a:r>
             <a:endParaRPr lang="en-US" sz="1200" dirty="0"/>
           </a:p>
@@ -10058,14 +10151,46 @@
               <a:buNone/>
             </a:pPr>
             <a:r>
-              <a:rPr lang="en-US" sz="1000" b="1" dirty="0">
+              <a:rPr lang="en-US" sz="1400" b="1" dirty="0">
                 <a:solidFill>
                   <a:srgbClr val="F4820A"/>
                 </a:solidFill>
               </a:rPr>
-              <a:t>El instructor hace (en GitHub.com):</a:t>
-            </a:r>
-            <a:endParaRPr lang="en-US" sz="1000" dirty="0"/>
+              <a:t>Si hay </a:t>
+            </a:r>
+            <a:r>
+              <a:rPr lang="en-US" sz="1400" b="1" dirty="0" err="1">
+                <a:solidFill>
+                  <a:srgbClr val="F4820A"/>
+                </a:solidFill>
+              </a:rPr>
+              <a:t>conflictos</a:t>
+            </a:r>
+            <a:r>
+              <a:rPr lang="en-US" sz="1400" b="1" dirty="0">
+                <a:solidFill>
+                  <a:srgbClr val="F4820A"/>
+                </a:solidFill>
+              </a:rPr>
+              <a:t>, </a:t>
+            </a:r>
+            <a:r>
+              <a:rPr lang="en-US" sz="1400" b="1" dirty="0" err="1">
+                <a:solidFill>
+                  <a:srgbClr val="F4820A"/>
+                </a:solidFill>
+              </a:rPr>
+              <a:t>el</a:t>
+            </a:r>
+            <a:r>
+              <a:rPr lang="en-US" sz="1400" b="1" dirty="0">
+                <a:solidFill>
+                  <a:srgbClr val="F4820A"/>
+                </a:solidFill>
+              </a:rPr>
+              <a:t> instructor (en GitHub.com):</a:t>
+            </a:r>
+            <a:endParaRPr lang="en-US" sz="1400" dirty="0"/>
           </a:p>
         </p:txBody>
       </p:sp>
@@ -10429,7 +10554,31 @@
                   <a:srgbClr val="FFFFFF"/>
                 </a:solidFill>
               </a:rPr>
-              <a:t>Revisa los cambios en la pestana Files changed</a:t>
+              <a:t>Revisa los cambios en la pestana Files changed y </a:t>
+            </a:r>
+            <a:r>
+              <a:rPr lang="en-US" sz="1100" dirty="0" err="1">
+                <a:solidFill>
+                  <a:srgbClr val="FFFFFF"/>
+                </a:solidFill>
+              </a:rPr>
+              <a:t>corrige</a:t>
+            </a:r>
+            <a:r>
+              <a:rPr lang="en-US" sz="1100" dirty="0">
+                <a:solidFill>
+                  <a:srgbClr val="FFFFFF"/>
+                </a:solidFill>
+              </a:rPr>
+              <a:t> </a:t>
+            </a:r>
+            <a:r>
+              <a:rPr lang="en-US" sz="1100" dirty="0" err="1">
+                <a:solidFill>
+                  <a:srgbClr val="FFFFFF"/>
+                </a:solidFill>
+              </a:rPr>
+              <a:t>errores</a:t>
             </a:r>
             <a:endParaRPr lang="en-US" sz="1100" dirty="0"/>
           </a:p>
@@ -10551,7 +10700,7 @@
                   <a:srgbClr val="FFFFFF"/>
                 </a:solidFill>
               </a:rPr>
-              <a:t>Clic en Merge pull request → Confirm merge</a:t>
+              <a:t>Click en Merge pull request → Confirm merge</a:t>
             </a:r>
             <a:endParaRPr lang="en-US" sz="1100" dirty="0"/>
           </a:p>
@@ -10673,7 +10822,15 @@
                   <a:srgbClr val="FFFFFF"/>
                 </a:solidFill>
               </a:rPr>
-              <a:t>Tu rama queda fusionada con main</a:t>
+              <a:t>Tu rama queda fusionada con main sin </a:t>
+            </a:r>
+            <a:r>
+              <a:rPr lang="en-US" sz="1100" dirty="0" err="1">
+                <a:solidFill>
+                  <a:srgbClr val="FFFFFF"/>
+                </a:solidFill>
+              </a:rPr>
+              <a:t>conflictos</a:t>
             </a:r>
             <a:endParaRPr lang="en-US" sz="1100" dirty="0"/>
           </a:p>
@@ -10729,14 +10886,46 @@
               <a:buNone/>
             </a:pPr>
             <a:r>
-              <a:rPr lang="en-US" sz="1000" b="1" dirty="0">
+              <a:rPr lang="en-US" sz="1200" b="1" dirty="0">
                 <a:solidFill>
                   <a:srgbClr val="F4820A"/>
                 </a:solidFill>
               </a:rPr>
-              <a:t>Vos: actualiza tu copia local con el merge</a:t>
-            </a:r>
-            <a:endParaRPr lang="en-US" sz="1000" dirty="0"/>
+              <a:t>Lo que </a:t>
+            </a:r>
+            <a:r>
+              <a:rPr lang="en-US" sz="1200" b="1" dirty="0" err="1">
+                <a:solidFill>
+                  <a:srgbClr val="F4820A"/>
+                </a:solidFill>
+              </a:rPr>
+              <a:t>tú</a:t>
+            </a:r>
+            <a:r>
+              <a:rPr lang="en-US" sz="1200" b="1" dirty="0">
+                <a:solidFill>
+                  <a:srgbClr val="F4820A"/>
+                </a:solidFill>
+              </a:rPr>
+              <a:t> </a:t>
+            </a:r>
+            <a:r>
+              <a:rPr lang="en-US" sz="1200" b="1" dirty="0" err="1">
+                <a:solidFill>
+                  <a:srgbClr val="F4820A"/>
+                </a:solidFill>
+              </a:rPr>
+              <a:t>haces</a:t>
+            </a:r>
+            <a:r>
+              <a:rPr lang="en-US" sz="1200" b="1" dirty="0">
+                <a:solidFill>
+                  <a:srgbClr val="F4820A"/>
+                </a:solidFill>
+              </a:rPr>
+              <a:t>: actualiza tu copia local con el merge</a:t>
+            </a:r>
+            <a:endParaRPr lang="en-US" sz="1200" dirty="0"/>
           </a:p>
         </p:txBody>
       </p:sp>
@@ -11125,7 +11314,7 @@
         </p:nvSpPr>
         <p:spPr>
           <a:xfrm>
-            <a:off x="5056632" y="3931920"/>
+            <a:off x="5042916" y="3845718"/>
             <a:ext cx="3730752" cy="274320"/>
           </a:xfrm>
           <a:prstGeom prst="rect">
@@ -11242,7 +11431,7 @@
         </p:nvSpPr>
         <p:spPr>
           <a:xfrm>
-            <a:off x="5056632" y="4864608"/>
+            <a:off x="5029200" y="4051458"/>
             <a:ext cx="3730752" cy="274320"/>
           </a:xfrm>
           <a:prstGeom prst="rect">
@@ -13169,7 +13358,55 @@
                   <a:srgbClr val="F4820A"/>
                 </a:solidFill>
               </a:rPr>
-              <a:t>Seguí aprendiendo:</a:t>
+              <a:t>Si </a:t>
+            </a:r>
+            <a:r>
+              <a:rPr lang="en-US" sz="1400" b="1" dirty="0" err="1">
+                <a:solidFill>
+                  <a:srgbClr val="F4820A"/>
+                </a:solidFill>
+              </a:rPr>
+              <a:t>quieres</a:t>
+            </a:r>
+            <a:r>
+              <a:rPr lang="en-US" sz="1400" b="1" dirty="0">
+                <a:solidFill>
+                  <a:srgbClr val="F4820A"/>
+                </a:solidFill>
+              </a:rPr>
+              <a:t> </a:t>
+            </a:r>
+            <a:r>
+              <a:rPr lang="en-US" sz="1400" b="1" dirty="0" err="1">
+                <a:solidFill>
+                  <a:srgbClr val="F4820A"/>
+                </a:solidFill>
+              </a:rPr>
+              <a:t>seguir</a:t>
+            </a:r>
+            <a:r>
+              <a:rPr lang="en-US" sz="1400" b="1" dirty="0">
+                <a:solidFill>
+                  <a:srgbClr val="F4820A"/>
+                </a:solidFill>
+              </a:rPr>
+              <a:t> </a:t>
+            </a:r>
+            <a:r>
+              <a:rPr lang="en-US" sz="1400" b="1" dirty="0" err="1">
+                <a:solidFill>
+                  <a:srgbClr val="F4820A"/>
+                </a:solidFill>
+              </a:rPr>
+              <a:t>aprendiendo</a:t>
+            </a:r>
+            <a:r>
+              <a:rPr lang="en-US" sz="1400" b="1" dirty="0">
+                <a:solidFill>
+                  <a:srgbClr val="F4820A"/>
+                </a:solidFill>
+              </a:rPr>
+              <a:t>:</a:t>
             </a:r>
             <a:endParaRPr lang="en-US" sz="1400" dirty="0"/>
           </a:p>

</xml_diff>